<commit_message>
Fix a false claim about ReFi-GAD ablation numbers; rebuild demo; rewrite README
The example deck and SKILL.md asserted that the ReFi-GAD paper's
ablation numbers disagree between the body text (20.39% / 0.70%) and
Table 2 (24.10 / 0.88). That assertion was wrong: the body numbers
come from Appendix Table 8 over all 14 datasets, while Table 2 covers
only the 7 Group 2 datasets. The paper is self-consistent. The claim
named a real, published paper, so it had to be corrected.

- assets/example_deck.js: reword the 4 places that made the claim
- SKILL.md: replace the "numbers disagree" guidance with "check the
  statistical scope first", and add the matching common-mistake entry
- demo/GAD_demo.pptx: rebuilt; presenter 张三; the five paper figures
  are replaced by placeholder images; layout check clean
- docs/showcase.png: regenerated from the new demo
- README.md: new version
- .gitignore: ignore *.zip
</commit_message>
<xml_diff>
--- a/demo/GAD_demo.pptx
+++ b/demo/GAD_demo.pptx
@@ -1149,7 +1149,7 @@
           <a:p>
             <a:r>
               <a:rPr lang="en-US" dirty="0"/>
-              <a:t>注意：正文写 w/o R、w/o D 提升 20.39%、0.70%，按表 2 计算是 24.10、0.88，结论不变，引用时以表格为准。</a:t>
+              <a:t>表 2 只列了 Group 2 的 7 个数据集，所以这里是 −24.10 / −0.88；正文的 20.39% / 0.70% 是附录 Table 8 全部 14 个数据集的结果（85.08 vs 64.69 / 84.38）。两者一致，引用时注明统计范围。</a:t>
             </a:r>
             <a:endParaRPr lang="en-US" dirty="0"/>
           </a:p>
@@ -2293,7 +2293,7 @@
           <a:p>
             <a:r>
               <a:rPr lang="en-US" dirty="0"/>
-              <a:t>第二篇里 ReFi-GAD 只有 81.22，比第一篇自报的 85.08 低，原因是支撑集从 50 降到 30。</a:t>
+              <a:t>第二篇里 ReFi-GAD 为 81.22，低于第一篇自报的 85.08。两篇的支撑集大小不同（50 vs 30），差异可能与此有关，但论文没有单独验证。</a:t>
             </a:r>
             <a:endParaRPr lang="en-US" dirty="0"/>
           </a:p>
@@ -3662,8 +3662,8 @@
         </p:nvSpPr>
         <p:spPr>
           <a:xfrm>
-            <a:off x="502920" y="914400"/>
-            <a:ext cx="3474720" cy="457200"/>
+            <a:off x="457200" y="777240"/>
+            <a:ext cx="3200400" cy="365760"/>
           </a:xfrm>
           <a:prstGeom prst="rect">
             <a:avLst/>
@@ -3679,30 +3679,557 @@
               <a:buNone/>
             </a:pPr>
             <a:r>
-              <a:rPr lang="en-US" sz="2200" spc="400" kern="0" dirty="0">
-                <a:solidFill>
-                  <a:srgbClr val="AB9ED4"/>
+              <a:rPr lang="zh-CN" altLang="en-US" sz="1500" b="1" spc="200" kern="0" dirty="0">
+                <a:solidFill>
+                  <a:srgbClr val="FFFFFF"/>
+                </a:solidFill>
+                <a:latin typeface="Times New Roman" pitchFamily="34" charset="0"/>
+                <a:ea typeface="宋体" pitchFamily="2" charset="-122"/>
+                <a:cs typeface="Times New Roman" pitchFamily="34" charset="-120"/>
+              </a:rPr>
+              <a:t>方向概览</a:t>
+            </a:r>
+            <a:endParaRPr lang="en-US" sz="1500" dirty="0"/>
+          </a:p>
+        </p:txBody>
+      </p:sp>
+      <p:sp>
+        <p:nvSpPr>
+          <p:cNvPr id="4" name="Shape 2"/>
+          <p:cNvSpPr/>
+          <p:nvPr/>
+        </p:nvSpPr>
+        <p:spPr>
+          <a:xfrm>
+            <a:off x="457200" y="1188720"/>
+            <a:ext cx="548640" cy="45720"/>
+          </a:xfrm>
+          <a:prstGeom prst="rect">
+            <a:avLst/>
+          </a:prstGeom>
+          <a:solidFill>
+            <a:srgbClr val="FFFFFF"/>
+          </a:solidFill>
+          <a:ln/>
+        </p:spPr>
+      </p:sp>
+      <p:sp>
+        <p:nvSpPr>
+          <p:cNvPr id="5" name="Shape 3"/>
+          <p:cNvSpPr/>
+          <p:nvPr/>
+        </p:nvSpPr>
+        <p:spPr>
+          <a:xfrm>
+            <a:off x="457200" y="1463040"/>
+            <a:ext cx="3200400" cy="841248"/>
+          </a:xfrm>
+          <a:prstGeom prst="rect">
+            <a:avLst/>
+          </a:prstGeom>
+          <a:ln w="15875">
+            <a:solidFill>
+              <a:srgbClr val="FFFFFF"/>
+            </a:solidFill>
+            <a:prstDash val="solid"/>
+          </a:ln>
+        </p:spPr>
+      </p:sp>
+      <p:sp>
+        <p:nvSpPr>
+          <p:cNvPr id="6" name="Text 4"/>
+          <p:cNvSpPr/>
+          <p:nvPr/>
+        </p:nvSpPr>
+        <p:spPr>
+          <a:xfrm>
+            <a:off x="512064" y="1463040"/>
+            <a:ext cx="3090672" cy="841248"/>
+          </a:xfrm>
+          <a:prstGeom prst="rect">
+            <a:avLst/>
+          </a:prstGeom>
+          <a:noFill/>
+          <a:ln/>
+        </p:spPr>
+        <p:txBody>
+          <a:bodyPr wrap="square" lIns="0" tIns="0" rIns="0" bIns="0" rtlCol="0" anchor="ctr"/>
+          <a:lstStyle/>
+          <a:p>
+            <a:pPr algn="ctr" indent="0" marL="0">
+              <a:buNone/>
+            </a:pPr>
+            <a:r>
+              <a:rPr lang="zh-CN" altLang="en-US" sz="1600" b="1" dirty="0">
+                <a:solidFill>
+                  <a:srgbClr val="FFFFFF"/>
+                </a:solidFill>
+                <a:latin typeface="Times New Roman" pitchFamily="34" charset="0"/>
+                <a:ea typeface="宋体" pitchFamily="2" charset="-122"/>
+                <a:cs typeface="Times New Roman" pitchFamily="34" charset="-120"/>
+              </a:rPr>
+              <a:t>传统 GAD</a:t>
+            </a:r>
+            <a:endParaRPr lang="en-US" sz="1600" dirty="0"/>
+          </a:p>
+          <a:p>
+            <a:pPr algn="ctr" indent="0" marL="0">
+              <a:buNone/>
+            </a:pPr>
+            <a:r>
+              <a:rPr lang="zh-CN" altLang="en-US" sz="1200" dirty="0">
+                <a:solidFill>
+                  <a:srgbClr val="D1C9E7"/>
+                </a:solidFill>
+                <a:latin typeface="Times New Roman" pitchFamily="34" charset="0"/>
+                <a:ea typeface="宋体" pitchFamily="2" charset="-122"/>
+                <a:cs typeface="Times New Roman" pitchFamily="34" charset="-120"/>
+              </a:rPr>
+              <a:t>每张图单独训练</a:t>
+            </a:r>
+            <a:endParaRPr lang="en-US" sz="1600" dirty="0"/>
+          </a:p>
+        </p:txBody>
+      </p:sp>
+      <p:sp>
+        <p:nvSpPr>
+          <p:cNvPr id="7" name="Shape 5"/>
+          <p:cNvSpPr/>
+          <p:nvPr/>
+        </p:nvSpPr>
+        <p:spPr>
+          <a:xfrm>
+            <a:off x="2057400" y="2350008"/>
+            <a:ext cx="0" cy="219456"/>
+          </a:xfrm>
+          <a:prstGeom prst="line">
+            <a:avLst/>
+          </a:prstGeom>
+          <a:noFill/>
+          <a:ln w="19050">
+            <a:solidFill>
+              <a:srgbClr val="FFFFFF"/>
+            </a:solidFill>
+            <a:prstDash val="solid"/>
+            <a:tailEnd type="triangle"/>
+          </a:ln>
+        </p:spPr>
+      </p:sp>
+      <p:sp>
+        <p:nvSpPr>
+          <p:cNvPr id="8" name="Shape 6"/>
+          <p:cNvSpPr/>
+          <p:nvPr/>
+        </p:nvSpPr>
+        <p:spPr>
+          <a:xfrm>
+            <a:off x="457200" y="2615184"/>
+            <a:ext cx="3200400" cy="841248"/>
+          </a:xfrm>
+          <a:prstGeom prst="rect">
+            <a:avLst/>
+          </a:prstGeom>
+          <a:ln w="15875">
+            <a:solidFill>
+              <a:srgbClr val="FFFFFF"/>
+            </a:solidFill>
+            <a:prstDash val="solid"/>
+          </a:ln>
+        </p:spPr>
+      </p:sp>
+      <p:sp>
+        <p:nvSpPr>
+          <p:cNvPr id="9" name="Text 7"/>
+          <p:cNvSpPr/>
+          <p:nvPr/>
+        </p:nvSpPr>
+        <p:spPr>
+          <a:xfrm>
+            <a:off x="512064" y="2615184"/>
+            <a:ext cx="3090672" cy="841248"/>
+          </a:xfrm>
+          <a:prstGeom prst="rect">
+            <a:avLst/>
+          </a:prstGeom>
+          <a:noFill/>
+          <a:ln/>
+        </p:spPr>
+        <p:txBody>
+          <a:bodyPr wrap="square" lIns="0" tIns="0" rIns="0" bIns="0" rtlCol="0" anchor="ctr"/>
+          <a:lstStyle/>
+          <a:p>
+            <a:pPr algn="ctr" indent="0" marL="0">
+              <a:buNone/>
+            </a:pPr>
+            <a:r>
+              <a:rPr lang="zh-CN" altLang="en-US" sz="1600" b="1" dirty="0">
+                <a:solidFill>
+                  <a:srgbClr val="FFFFFF"/>
+                </a:solidFill>
+                <a:latin typeface="Times New Roman" pitchFamily="34" charset="0"/>
+                <a:ea typeface="宋体" pitchFamily="2" charset="-122"/>
+                <a:cs typeface="Times New Roman" pitchFamily="34" charset="-120"/>
+              </a:rPr>
+              <a:t>通用 GAD</a:t>
+            </a:r>
+            <a:endParaRPr lang="en-US" sz="1600" dirty="0"/>
+          </a:p>
+          <a:p>
+            <a:pPr algn="ctr" indent="0" marL="0">
+              <a:buNone/>
+            </a:pPr>
+            <a:r>
+              <a:rPr lang="zh-CN" altLang="en-US" sz="1200" dirty="0">
+                <a:solidFill>
+                  <a:srgbClr val="D1C9E7"/>
+                </a:solidFill>
+                <a:latin typeface="Times New Roman" pitchFamily="34" charset="0"/>
+                <a:ea typeface="宋体" pitchFamily="2" charset="-122"/>
+                <a:cs typeface="Times New Roman" pitchFamily="34" charset="-120"/>
+              </a:rPr>
+              <a:t>训练一次，迁移到新图</a:t>
+            </a:r>
+            <a:endParaRPr lang="en-US" sz="1600" dirty="0"/>
+          </a:p>
+        </p:txBody>
+      </p:sp>
+      <p:sp>
+        <p:nvSpPr>
+          <p:cNvPr id="10" name="Shape 8"/>
+          <p:cNvSpPr/>
+          <p:nvPr/>
+        </p:nvSpPr>
+        <p:spPr>
+          <a:xfrm>
+            <a:off x="2057400" y="3502152"/>
+            <a:ext cx="0" cy="219456"/>
+          </a:xfrm>
+          <a:prstGeom prst="line">
+            <a:avLst/>
+          </a:prstGeom>
+          <a:noFill/>
+          <a:ln w="19050">
+            <a:solidFill>
+              <a:srgbClr val="FFFFFF"/>
+            </a:solidFill>
+            <a:prstDash val="solid"/>
+            <a:tailEnd type="triangle"/>
+          </a:ln>
+        </p:spPr>
+      </p:sp>
+      <p:sp>
+        <p:nvSpPr>
+          <p:cNvPr id="11" name="Shape 9"/>
+          <p:cNvSpPr/>
+          <p:nvPr/>
+        </p:nvSpPr>
+        <p:spPr>
+          <a:xfrm>
+            <a:off x="457200" y="3767328"/>
+            <a:ext cx="3200400" cy="841248"/>
+          </a:xfrm>
+          <a:prstGeom prst="rect">
+            <a:avLst/>
+          </a:prstGeom>
+          <a:ln w="15875">
+            <a:solidFill>
+              <a:srgbClr val="FFFFFF"/>
+            </a:solidFill>
+            <a:prstDash val="solid"/>
+          </a:ln>
+        </p:spPr>
+      </p:sp>
+      <p:sp>
+        <p:nvSpPr>
+          <p:cNvPr id="12" name="Text 10"/>
+          <p:cNvSpPr/>
+          <p:nvPr/>
+        </p:nvSpPr>
+        <p:spPr>
+          <a:xfrm>
+            <a:off x="512064" y="3767328"/>
+            <a:ext cx="3090672" cy="841248"/>
+          </a:xfrm>
+          <a:prstGeom prst="rect">
+            <a:avLst/>
+          </a:prstGeom>
+          <a:noFill/>
+          <a:ln/>
+        </p:spPr>
+        <p:txBody>
+          <a:bodyPr wrap="square" lIns="0" tIns="0" rIns="0" bIns="0" rtlCol="0" anchor="ctr"/>
+          <a:lstStyle/>
+          <a:p>
+            <a:pPr algn="ctr" indent="0" marL="0">
+              <a:buNone/>
+            </a:pPr>
+            <a:r>
+              <a:rPr lang="zh-CN" altLang="en-US" sz="1600" b="1" dirty="0">
+                <a:solidFill>
+                  <a:srgbClr val="FFFFFF"/>
+                </a:solidFill>
+                <a:latin typeface="Times New Roman" pitchFamily="34" charset="0"/>
+                <a:ea typeface="宋体" pitchFamily="2" charset="-122"/>
+                <a:cs typeface="Times New Roman" pitchFamily="34" charset="-120"/>
+              </a:rPr>
+              <a:t>两个瓶颈</a:t>
+            </a:r>
+            <a:endParaRPr lang="en-US" sz="1600" dirty="0"/>
+          </a:p>
+          <a:p>
+            <a:pPr algn="ctr" indent="0" marL="0">
+              <a:buNone/>
+            </a:pPr>
+            <a:r>
+              <a:rPr lang="zh-CN" altLang="en-US" sz="1200" dirty="0">
+                <a:solidFill>
+                  <a:srgbClr val="D1C9E7"/>
+                </a:solidFill>
+                <a:latin typeface="Times New Roman" pitchFamily="34" charset="0"/>
+                <a:ea typeface="宋体" pitchFamily="2" charset="-122"/>
+                <a:cs typeface="Times New Roman" pitchFamily="34" charset="-120"/>
+              </a:rPr>
+              <a:t>特征异质 · 数据稀缺</a:t>
+            </a:r>
+            <a:endParaRPr lang="en-US" sz="1600" dirty="0"/>
+          </a:p>
+        </p:txBody>
+      </p:sp>
+      <p:sp>
+        <p:nvSpPr>
+          <p:cNvPr id="13" name="Shape 11"/>
+          <p:cNvSpPr/>
+          <p:nvPr/>
+        </p:nvSpPr>
+        <p:spPr>
+          <a:xfrm>
+            <a:off x="2057400" y="4654296"/>
+            <a:ext cx="0" cy="219456"/>
+          </a:xfrm>
+          <a:prstGeom prst="line">
+            <a:avLst/>
+          </a:prstGeom>
+          <a:noFill/>
+          <a:ln w="19050">
+            <a:solidFill>
+              <a:srgbClr val="FFFFFF"/>
+            </a:solidFill>
+            <a:prstDash val="solid"/>
+            <a:tailEnd type="triangle"/>
+          </a:ln>
+        </p:spPr>
+      </p:sp>
+      <p:sp>
+        <p:nvSpPr>
+          <p:cNvPr id="14" name="Shape 12"/>
+          <p:cNvSpPr/>
+          <p:nvPr/>
+        </p:nvSpPr>
+        <p:spPr>
+          <a:xfrm>
+            <a:off x="457200" y="4919472"/>
+            <a:ext cx="1527048" cy="841248"/>
+          </a:xfrm>
+          <a:prstGeom prst="rect">
+            <a:avLst/>
+          </a:prstGeom>
+          <a:solidFill>
+            <a:srgbClr val="FFFFFF"/>
+          </a:solidFill>
+          <a:ln w="15875">
+            <a:solidFill>
+              <a:srgbClr val="FFFFFF"/>
+            </a:solidFill>
+            <a:prstDash val="solid"/>
+          </a:ln>
+        </p:spPr>
+      </p:sp>
+      <p:sp>
+        <p:nvSpPr>
+          <p:cNvPr id="15" name="Text 13"/>
+          <p:cNvSpPr/>
+          <p:nvPr/>
+        </p:nvSpPr>
+        <p:spPr>
+          <a:xfrm>
+            <a:off x="512064" y="4919472"/>
+            <a:ext cx="1417320" cy="841248"/>
+          </a:xfrm>
+          <a:prstGeom prst="rect">
+            <a:avLst/>
+          </a:prstGeom>
+          <a:noFill/>
+          <a:ln/>
+        </p:spPr>
+        <p:txBody>
+          <a:bodyPr wrap="square" lIns="0" tIns="0" rIns="0" bIns="0" rtlCol="0" anchor="ctr"/>
+          <a:lstStyle/>
+          <a:p>
+            <a:pPr algn="ctr" indent="0" marL="0">
+              <a:buNone/>
+            </a:pPr>
+            <a:r>
+              <a:rPr lang="en-US" altLang="en-US" sz="1400" b="1" dirty="0">
+                <a:solidFill>
+                  <a:srgbClr val="4527A0"/>
+                </a:solidFill>
+                <a:latin typeface="Times New Roman" pitchFamily="34" charset="0"/>
+                <a:ea typeface="宋体" pitchFamily="2" charset="-122"/>
+                <a:cs typeface="Times New Roman" pitchFamily="34" charset="-120"/>
+              </a:rPr>
+              <a:t>ReFi-GAD</a:t>
+            </a:r>
+            <a:endParaRPr lang="en-US" sz="1400" dirty="0"/>
+          </a:p>
+          <a:p>
+            <a:pPr algn="ctr" indent="0" marL="0">
+              <a:buNone/>
+            </a:pPr>
+            <a:r>
+              <a:rPr lang="zh-CN" altLang="en-US" sz="1050" dirty="0">
+                <a:solidFill>
+                  <a:srgbClr val="555555"/>
+                </a:solidFill>
+                <a:latin typeface="Times New Roman" pitchFamily="34" charset="0"/>
+                <a:ea typeface="宋体" pitchFamily="2" charset="-122"/>
+                <a:cs typeface="Times New Roman" pitchFamily="34" charset="-120"/>
+              </a:rPr>
+              <a:t>关系指纹对齐特征</a:t>
+            </a:r>
+            <a:endParaRPr lang="en-US" sz="1400" dirty="0"/>
+          </a:p>
+        </p:txBody>
+      </p:sp>
+      <p:sp>
+        <p:nvSpPr>
+          <p:cNvPr id="16" name="Shape 14"/>
+          <p:cNvSpPr/>
+          <p:nvPr/>
+        </p:nvSpPr>
+        <p:spPr>
+          <a:xfrm>
+            <a:off x="2130552" y="4919472"/>
+            <a:ext cx="1527048" cy="841248"/>
+          </a:xfrm>
+          <a:prstGeom prst="rect">
+            <a:avLst/>
+          </a:prstGeom>
+          <a:solidFill>
+            <a:srgbClr val="FFFFFF"/>
+          </a:solidFill>
+          <a:ln w="15875">
+            <a:solidFill>
+              <a:srgbClr val="FFFFFF"/>
+            </a:solidFill>
+            <a:prstDash val="solid"/>
+          </a:ln>
+        </p:spPr>
+      </p:sp>
+      <p:sp>
+        <p:nvSpPr>
+          <p:cNvPr id="17" name="Text 15"/>
+          <p:cNvSpPr/>
+          <p:nvPr/>
+        </p:nvSpPr>
+        <p:spPr>
+          <a:xfrm>
+            <a:off x="2185416" y="4919472"/>
+            <a:ext cx="1417320" cy="841248"/>
+          </a:xfrm>
+          <a:prstGeom prst="rect">
+            <a:avLst/>
+          </a:prstGeom>
+          <a:noFill/>
+          <a:ln/>
+        </p:spPr>
+        <p:txBody>
+          <a:bodyPr wrap="square" lIns="0" tIns="0" rIns="0" bIns="0" rtlCol="0" anchor="ctr"/>
+          <a:lstStyle/>
+          <a:p>
+            <a:pPr algn="ctr" indent="0" marL="0">
+              <a:buNone/>
+            </a:pPr>
+            <a:r>
+              <a:rPr lang="en-US" altLang="en-US" sz="1400" b="1" dirty="0">
+                <a:solidFill>
+                  <a:srgbClr val="4527A0"/>
+                </a:solidFill>
+                <a:latin typeface="Times New Roman" pitchFamily="34" charset="0"/>
+                <a:ea typeface="宋体" pitchFamily="2" charset="-122"/>
+                <a:cs typeface="Times New Roman" pitchFamily="34" charset="-120"/>
+              </a:rPr>
+              <a:t>AG-Forge</a:t>
+            </a:r>
+            <a:endParaRPr lang="en-US" sz="1400" dirty="0"/>
+          </a:p>
+          <a:p>
+            <a:pPr algn="ctr" indent="0" marL="0">
+              <a:buNone/>
+            </a:pPr>
+            <a:r>
+              <a:rPr lang="zh-CN" altLang="en-US" sz="1050" dirty="0">
+                <a:solidFill>
+                  <a:srgbClr val="555555"/>
+                </a:solidFill>
+                <a:latin typeface="Times New Roman" pitchFamily="34" charset="0"/>
+                <a:ea typeface="宋体" pitchFamily="2" charset="-122"/>
+                <a:cs typeface="Times New Roman" pitchFamily="34" charset="-120"/>
+              </a:rPr>
+              <a:t>合成数据训练</a:t>
+            </a:r>
+            <a:endParaRPr lang="en-US" sz="1400" dirty="0"/>
+          </a:p>
+        </p:txBody>
+      </p:sp>
+      <p:sp>
+        <p:nvSpPr>
+          <p:cNvPr id="18" name="Text 16"/>
+          <p:cNvSpPr/>
+          <p:nvPr/>
+        </p:nvSpPr>
+        <p:spPr>
+          <a:xfrm>
+            <a:off x="502920" y="6035040"/>
+            <a:ext cx="3474720" cy="457200"/>
+          </a:xfrm>
+          <a:prstGeom prst="rect">
+            <a:avLst/>
+          </a:prstGeom>
+          <a:noFill/>
+          <a:ln/>
+        </p:spPr>
+        <p:txBody>
+          <a:bodyPr wrap="square" lIns="0" tIns="0" rIns="0" bIns="0" rtlCol="0" anchor="ctr"/>
+          <a:lstStyle/>
+          <a:p>
+            <a:pPr algn="l" indent="0" marL="0">
+              <a:buNone/>
+            </a:pPr>
+            <a:r>
+              <a:rPr lang="en-US" sz="1600" b="1" i="1" dirty="0">
+                <a:solidFill>
+                  <a:srgbClr val="FFFFFF"/>
                 </a:solidFill>
                 <a:latin typeface="Consolas" pitchFamily="34" charset="0"/>
                 <a:ea typeface="Consolas" pitchFamily="34" charset="-122"/>
                 <a:cs typeface="Consolas" pitchFamily="34" charset="-120"/>
               </a:rPr>
-              <a:t>0 1 1 0 0 1 0</a:t>
-            </a:r>
-            <a:endParaRPr lang="en-US" sz="2200" dirty="0"/>
+              <a:t># Generalist GAD</a:t>
+            </a:r>
+            <a:endParaRPr lang="en-US" sz="1600" dirty="0"/>
           </a:p>
         </p:txBody>
       </p:sp>
       <p:sp>
         <p:nvSpPr>
-          <p:cNvPr id="4" name="Text 2"/>
-          <p:cNvSpPr/>
-          <p:nvPr/>
-        </p:nvSpPr>
-        <p:spPr>
-          <a:xfrm>
-            <a:off x="502920" y="1417320"/>
-            <a:ext cx="3474720" cy="457200"/>
+          <p:cNvPr id="19" name="Text 17"/>
+          <p:cNvSpPr/>
+          <p:nvPr/>
+        </p:nvSpPr>
+        <p:spPr>
+          <a:xfrm>
+            <a:off x="4572000" y="1005840"/>
+            <a:ext cx="7162495" cy="1330960"/>
           </a:xfrm>
           <a:prstGeom prst="rect">
             <a:avLst/>
@@ -3718,30 +4245,47 @@
               <a:buNone/>
             </a:pPr>
             <a:r>
-              <a:rPr lang="en-US" sz="2200" spc="400" kern="0" dirty="0">
-                <a:solidFill>
-                  <a:srgbClr val="AB9ED4"/>
-                </a:solidFill>
-                <a:latin typeface="Consolas" pitchFamily="34" charset="0"/>
-                <a:ea typeface="Consolas" pitchFamily="34" charset="-122"/>
-                <a:cs typeface="Consolas" pitchFamily="34" charset="-120"/>
-              </a:rPr>
-              <a:t>1 0 1 0 1 0 0</a:t>
-            </a:r>
-            <a:endParaRPr lang="en-US" sz="2200" dirty="0"/>
+              <a:rPr lang="zh-CN" altLang="en-US" sz="4000" b="1" dirty="0">
+                <a:solidFill>
+                  <a:srgbClr val="4527A0"/>
+                </a:solidFill>
+                <a:latin typeface="Times New Roman" pitchFamily="34" charset="0"/>
+                <a:ea typeface="宋体" pitchFamily="2" charset="-122"/>
+                <a:cs typeface="Times New Roman" pitchFamily="34" charset="-120"/>
+              </a:rPr>
+              <a:t>通用图异常检测：</a:t>
+            </a:r>
+            <a:endParaRPr lang="en-US" sz="4000" dirty="0"/>
+          </a:p>
+          <a:p>
+            <a:pPr algn="l" indent="0" marL="0">
+              <a:buNone/>
+            </a:pPr>
+            <a:r>
+              <a:rPr lang="zh-CN" altLang="en-US" sz="4000" b="1" dirty="0">
+                <a:solidFill>
+                  <a:srgbClr val="4527A0"/>
+                </a:solidFill>
+                <a:latin typeface="Times New Roman" pitchFamily="34" charset="0"/>
+                <a:ea typeface="宋体" pitchFamily="2" charset="-122"/>
+                <a:cs typeface="Times New Roman" pitchFamily="34" charset="-120"/>
+              </a:rPr>
+              <a:t>从特征对齐到合成数据</a:t>
+            </a:r>
+            <a:endParaRPr lang="en-US" sz="4000" dirty="0"/>
           </a:p>
         </p:txBody>
       </p:sp>
       <p:sp>
         <p:nvSpPr>
-          <p:cNvPr id="5" name="Text 3"/>
-          <p:cNvSpPr/>
-          <p:nvPr/>
-        </p:nvSpPr>
-        <p:spPr>
-          <a:xfrm>
-            <a:off x="502920" y="1920240"/>
-            <a:ext cx="3474720" cy="457200"/>
+          <p:cNvPr id="20" name="Text 18"/>
+          <p:cNvSpPr/>
+          <p:nvPr/>
+        </p:nvSpPr>
+        <p:spPr>
+          <a:xfrm>
+            <a:off x="4572000" y="2409952"/>
+            <a:ext cx="7162495" cy="594360"/>
           </a:xfrm>
           <a:prstGeom prst="rect">
             <a:avLst/>
@@ -3757,30 +4301,50 @@
               <a:buNone/>
             </a:pPr>
             <a:r>
-              <a:rPr lang="en-US" sz="2200" spc="400" kern="0" dirty="0">
-                <a:solidFill>
-                  <a:srgbClr val="AB9ED4"/>
-                </a:solidFill>
-                <a:latin typeface="Consolas" pitchFamily="34" charset="0"/>
-                <a:ea typeface="Consolas" pitchFamily="34" charset="-122"/>
-                <a:cs typeface="Consolas" pitchFamily="34" charset="-120"/>
-              </a:rPr>
-              <a:t>1 1 0 1 0 0 1</a:t>
-            </a:r>
-            <a:endParaRPr lang="en-US" sz="2200" dirty="0"/>
+              <a:rPr lang="zh-CN" altLang="en-US" sz="2600" dirty="0">
+                <a:solidFill>
+                  <a:srgbClr val="1A1A1A"/>
+                </a:solidFill>
+                <a:latin typeface="Times New Roman" pitchFamily="34" charset="0"/>
+                <a:ea typeface="宋体" pitchFamily="2" charset="-122"/>
+                <a:cs typeface="Times New Roman" pitchFamily="34" charset="-120"/>
+              </a:rPr>
+              <a:t>两篇 Generalist GAD 论文精读</a:t>
+            </a:r>
+            <a:endParaRPr lang="en-US" sz="2600" dirty="0"/>
           </a:p>
         </p:txBody>
       </p:sp>
       <p:sp>
         <p:nvSpPr>
-          <p:cNvPr id="6" name="Text 4"/>
-          <p:cNvSpPr/>
-          <p:nvPr/>
-        </p:nvSpPr>
-        <p:spPr>
-          <a:xfrm>
-            <a:off x="502920" y="2423160"/>
-            <a:ext cx="3474720" cy="457200"/>
+          <p:cNvPr id="21" name="Shape 19"/>
+          <p:cNvSpPr/>
+          <p:nvPr/>
+        </p:nvSpPr>
+        <p:spPr>
+          <a:xfrm>
+            <a:off x="4572000" y="3141472"/>
+            <a:ext cx="822960" cy="73152"/>
+          </a:xfrm>
+          <a:prstGeom prst="rect">
+            <a:avLst/>
+          </a:prstGeom>
+          <a:solidFill>
+            <a:srgbClr val="4527A0"/>
+          </a:solidFill>
+          <a:ln/>
+        </p:spPr>
+      </p:sp>
+      <p:sp>
+        <p:nvSpPr>
+          <p:cNvPr id="22" name="Text 20"/>
+          <p:cNvSpPr/>
+          <p:nvPr/>
+        </p:nvSpPr>
+        <p:spPr>
+          <a:xfrm>
+            <a:off x="4572000" y="3370072"/>
+            <a:ext cx="7162495" cy="411480"/>
           </a:xfrm>
           <a:prstGeom prst="rect">
             <a:avLst/>
@@ -3796,30 +4360,30 @@
               <a:buNone/>
             </a:pPr>
             <a:r>
-              <a:rPr lang="en-US" sz="2200" spc="400" kern="0" dirty="0">
-                <a:solidFill>
-                  <a:srgbClr val="AB9ED4"/>
-                </a:solidFill>
-                <a:latin typeface="Consolas" pitchFamily="34" charset="0"/>
-                <a:ea typeface="Consolas" pitchFamily="34" charset="-122"/>
-                <a:cs typeface="Consolas" pitchFamily="34" charset="-120"/>
-              </a:rPr>
-              <a:t>0 0 1 0 1 1 0</a:t>
-            </a:r>
-            <a:endParaRPr lang="en-US" sz="2200" dirty="0"/>
+              <a:rPr lang="en-US" altLang="en-US" sz="1800" i="1" dirty="0">
+                <a:solidFill>
+                  <a:srgbClr val="555555"/>
+                </a:solidFill>
+                <a:latin typeface="Times New Roman" pitchFamily="34" charset="0"/>
+                <a:ea typeface="宋体" pitchFamily="2" charset="-122"/>
+                <a:cs typeface="Times New Roman" pitchFamily="34" charset="-120"/>
+              </a:rPr>
+              <a:t>ReFi-GAD · Relational Fingerprints (ICML 2026)</a:t>
+            </a:r>
+            <a:endParaRPr lang="en-US" sz="1800" dirty="0"/>
           </a:p>
         </p:txBody>
       </p:sp>
       <p:sp>
         <p:nvSpPr>
-          <p:cNvPr id="7" name="Text 5"/>
-          <p:cNvSpPr/>
-          <p:nvPr/>
-        </p:nvSpPr>
-        <p:spPr>
-          <a:xfrm>
-            <a:off x="502920" y="2926080"/>
-            <a:ext cx="3474720" cy="457200"/>
+          <p:cNvPr id="23" name="Text 21"/>
+          <p:cNvSpPr/>
+          <p:nvPr/>
+        </p:nvSpPr>
+        <p:spPr>
+          <a:xfrm>
+            <a:off x="4572000" y="3781552"/>
+            <a:ext cx="7162495" cy="411480"/>
           </a:xfrm>
           <a:prstGeom prst="rect">
             <a:avLst/>
@@ -3835,30 +4399,50 @@
               <a:buNone/>
             </a:pPr>
             <a:r>
-              <a:rPr lang="en-US" sz="2200" spc="400" kern="0" dirty="0">
-                <a:solidFill>
-                  <a:srgbClr val="AB9ED4"/>
-                </a:solidFill>
-                <a:latin typeface="Consolas" pitchFamily="34" charset="0"/>
-                <a:ea typeface="Consolas" pitchFamily="34" charset="-122"/>
-                <a:cs typeface="Consolas" pitchFamily="34" charset="-120"/>
-              </a:rPr>
-              <a:t>0 1 0 1 1 0 1</a:t>
-            </a:r>
-            <a:endParaRPr lang="en-US" sz="2200" dirty="0"/>
+              <a:rPr lang="en-US" altLang="en-US" sz="1800" i="1" dirty="0">
+                <a:solidFill>
+                  <a:srgbClr val="555555"/>
+                </a:solidFill>
+                <a:latin typeface="Times New Roman" pitchFamily="34" charset="0"/>
+                <a:ea typeface="宋体" pitchFamily="2" charset="-122"/>
+                <a:cs typeface="Times New Roman" pitchFamily="34" charset="-120"/>
+              </a:rPr>
+              <a:t>AG-Forge + TS-GGAD · Synthetic Training (arXiv 2026)</a:t>
+            </a:r>
+            <a:endParaRPr lang="en-US" sz="1800" dirty="0"/>
           </a:p>
         </p:txBody>
       </p:sp>
       <p:sp>
         <p:nvSpPr>
-          <p:cNvPr id="8" name="Text 6"/>
-          <p:cNvSpPr/>
-          <p:nvPr/>
-        </p:nvSpPr>
-        <p:spPr>
-          <a:xfrm>
-            <a:off x="502920" y="6035040"/>
-            <a:ext cx="3474720" cy="457200"/>
+          <p:cNvPr id="24" name="Shape 22"/>
+          <p:cNvSpPr/>
+          <p:nvPr/>
+        </p:nvSpPr>
+        <p:spPr>
+          <a:xfrm>
+            <a:off x="4572000" y="5303520"/>
+            <a:ext cx="6858000" cy="36576"/>
+          </a:xfrm>
+          <a:prstGeom prst="rect">
+            <a:avLst/>
+          </a:prstGeom>
+          <a:solidFill>
+            <a:srgbClr val="E8E2F5"/>
+          </a:solidFill>
+          <a:ln/>
+        </p:spPr>
+      </p:sp>
+      <p:sp>
+        <p:nvSpPr>
+          <p:cNvPr id="25" name="Text 23"/>
+          <p:cNvSpPr/>
+          <p:nvPr/>
+        </p:nvSpPr>
+        <p:spPr>
+          <a:xfrm>
+            <a:off x="4572000" y="5486400"/>
+            <a:ext cx="7162495" cy="365760"/>
           </a:xfrm>
           <a:prstGeom prst="rect">
             <a:avLst/>
@@ -3874,30 +4458,44 @@
               <a:buNone/>
             </a:pPr>
             <a:r>
-              <a:rPr lang="en-US" sz="1600" b="1" i="1" dirty="0">
-                <a:solidFill>
-                  <a:srgbClr val="FFFFFF"/>
-                </a:solidFill>
-                <a:latin typeface="Consolas" pitchFamily="34" charset="0"/>
-                <a:ea typeface="Consolas" pitchFamily="34" charset="-122"/>
-                <a:cs typeface="Consolas" pitchFamily="34" charset="-120"/>
-              </a:rPr>
-              <a:t># Generalist GAD</a:t>
-            </a:r>
-            <a:endParaRPr lang="en-US" sz="1600" dirty="0"/>
+              <a:rPr lang="zh-CN" altLang="en-US" sz="1500" dirty="0">
+                <a:solidFill>
+                  <a:srgbClr val="999999"/>
+                </a:solidFill>
+                <a:latin typeface="Times New Roman" pitchFamily="34" charset="0"/>
+                <a:ea typeface="宋体" pitchFamily="2" charset="-122"/>
+                <a:cs typeface="Times New Roman" pitchFamily="34" charset="-120"/>
+              </a:rPr>
+              <a:t>汇 报 人：</a:t>
+            </a:r>
+            <a:pPr algn="l" indent="0" marL="0">
+              <a:buNone/>
+            </a:pPr>
+            <a:r>
+              <a:rPr lang="zh-CN" altLang="en-US" sz="1700" dirty="0">
+                <a:solidFill>
+                  <a:srgbClr val="1A1A1A"/>
+                </a:solidFill>
+                <a:latin typeface="Times New Roman" pitchFamily="34" charset="0"/>
+                <a:ea typeface="宋体" pitchFamily="2" charset="-122"/>
+                <a:cs typeface="Times New Roman" pitchFamily="34" charset="-120"/>
+              </a:rPr>
+              <a:t>张三</a:t>
+            </a:r>
+            <a:endParaRPr lang="en-US" sz="1500" dirty="0"/>
           </a:p>
         </p:txBody>
       </p:sp>
       <p:sp>
         <p:nvSpPr>
-          <p:cNvPr id="9" name="Text 7"/>
-          <p:cNvSpPr/>
-          <p:nvPr/>
-        </p:nvSpPr>
-        <p:spPr>
-          <a:xfrm>
-            <a:off x="4572000" y="1005840"/>
-            <a:ext cx="7162495" cy="1330960"/>
+          <p:cNvPr id="26" name="Text 24"/>
+          <p:cNvSpPr/>
+          <p:nvPr/>
+        </p:nvSpPr>
+        <p:spPr>
+          <a:xfrm>
+            <a:off x="4572000" y="5897880"/>
+            <a:ext cx="7162495" cy="365760"/>
           </a:xfrm>
           <a:prstGeom prst="rect">
             <a:avLst/>
@@ -3913,303 +4511,37 @@
               <a:buNone/>
             </a:pPr>
             <a:r>
-              <a:rPr lang="zh-CN" altLang="en-US" sz="4000" b="1" dirty="0">
-                <a:solidFill>
-                  <a:srgbClr val="4527A0"/>
-                </a:solidFill>
-                <a:latin typeface="Times New Roman" pitchFamily="34" charset="0"/>
-                <a:ea typeface="宋体" pitchFamily="2" charset="-122"/>
-                <a:cs typeface="Times New Roman" pitchFamily="34" charset="-120"/>
-              </a:rPr>
-              <a:t>通用图异常检测：</a:t>
-            </a:r>
-            <a:endParaRPr lang="en-US" sz="4000" dirty="0"/>
-          </a:p>
-          <a:p>
-            <a:pPr algn="l" indent="0" marL="0">
-              <a:buNone/>
-            </a:pPr>
-            <a:r>
-              <a:rPr lang="zh-CN" altLang="en-US" sz="4000" b="1" dirty="0">
-                <a:solidFill>
-                  <a:srgbClr val="4527A0"/>
-                </a:solidFill>
-                <a:latin typeface="Times New Roman" pitchFamily="34" charset="0"/>
-                <a:ea typeface="宋体" pitchFamily="2" charset="-122"/>
-                <a:cs typeface="Times New Roman" pitchFamily="34" charset="-120"/>
-              </a:rPr>
-              <a:t>从特征对齐到合成数据</a:t>
-            </a:r>
-            <a:endParaRPr lang="en-US" sz="4000" dirty="0"/>
+              <a:rPr lang="zh-CN" altLang="en-US" sz="1500" dirty="0">
+                <a:solidFill>
+                  <a:srgbClr val="999999"/>
+                </a:solidFill>
+                <a:latin typeface="Times New Roman" pitchFamily="34" charset="0"/>
+                <a:ea typeface="宋体" pitchFamily="2" charset="-122"/>
+                <a:cs typeface="Times New Roman" pitchFamily="34" charset="-120"/>
+              </a:rPr>
+              <a:t>论文作者：</a:t>
+            </a:r>
+            <a:pPr algn="l" indent="0" marL="0">
+              <a:buNone/>
+            </a:pPr>
+            <a:r>
+              <a:rPr lang="zh-CN" altLang="en-US" sz="1700" dirty="0">
+                <a:solidFill>
+                  <a:srgbClr val="1A1A1A"/>
+                </a:solidFill>
+                <a:latin typeface="Times New Roman" pitchFamily="34" charset="0"/>
+                <a:ea typeface="宋体" pitchFamily="2" charset="-122"/>
+                <a:cs typeface="Times New Roman" pitchFamily="34" charset="-120"/>
+              </a:rPr>
+              <a:t>Griffith University &amp; 同济大学</a:t>
+            </a:r>
+            <a:endParaRPr lang="en-US" sz="1500" dirty="0"/>
           </a:p>
         </p:txBody>
       </p:sp>
       <p:sp>
         <p:nvSpPr>
-          <p:cNvPr id="10" name="Text 8"/>
-          <p:cNvSpPr/>
-          <p:nvPr/>
-        </p:nvSpPr>
-        <p:spPr>
-          <a:xfrm>
-            <a:off x="4572000" y="2409952"/>
-            <a:ext cx="7162495" cy="594360"/>
-          </a:xfrm>
-          <a:prstGeom prst="rect">
-            <a:avLst/>
-          </a:prstGeom>
-          <a:noFill/>
-          <a:ln/>
-        </p:spPr>
-        <p:txBody>
-          <a:bodyPr wrap="square" lIns="0" tIns="0" rIns="0" bIns="0" rtlCol="0" anchor="ctr"/>
-          <a:lstStyle/>
-          <a:p>
-            <a:pPr algn="l" indent="0" marL="0">
-              <a:buNone/>
-            </a:pPr>
-            <a:r>
-              <a:rPr lang="zh-CN" altLang="en-US" sz="2600" dirty="0">
-                <a:solidFill>
-                  <a:srgbClr val="1A1A1A"/>
-                </a:solidFill>
-                <a:latin typeface="Times New Roman" pitchFamily="34" charset="0"/>
-                <a:ea typeface="宋体" pitchFamily="2" charset="-122"/>
-                <a:cs typeface="Times New Roman" pitchFamily="34" charset="-120"/>
-              </a:rPr>
-              <a:t>两篇 Generalist GAD 论文精读</a:t>
-            </a:r>
-            <a:endParaRPr lang="en-US" sz="2600" dirty="0"/>
-          </a:p>
-        </p:txBody>
-      </p:sp>
-      <p:sp>
-        <p:nvSpPr>
-          <p:cNvPr id="11" name="Shape 9"/>
-          <p:cNvSpPr/>
-          <p:nvPr/>
-        </p:nvSpPr>
-        <p:spPr>
-          <a:xfrm>
-            <a:off x="4572000" y="3141472"/>
-            <a:ext cx="822960" cy="73152"/>
-          </a:xfrm>
-          <a:prstGeom prst="rect">
-            <a:avLst/>
-          </a:prstGeom>
-          <a:solidFill>
-            <a:srgbClr val="4527A0"/>
-          </a:solidFill>
-          <a:ln/>
-        </p:spPr>
-      </p:sp>
-      <p:sp>
-        <p:nvSpPr>
-          <p:cNvPr id="12" name="Text 10"/>
-          <p:cNvSpPr/>
-          <p:nvPr/>
-        </p:nvSpPr>
-        <p:spPr>
-          <a:xfrm>
-            <a:off x="4572000" y="3370072"/>
-            <a:ext cx="7162495" cy="411480"/>
-          </a:xfrm>
-          <a:prstGeom prst="rect">
-            <a:avLst/>
-          </a:prstGeom>
-          <a:noFill/>
-          <a:ln/>
-        </p:spPr>
-        <p:txBody>
-          <a:bodyPr wrap="square" lIns="0" tIns="0" rIns="0" bIns="0" rtlCol="0" anchor="ctr"/>
-          <a:lstStyle/>
-          <a:p>
-            <a:pPr algn="l" indent="0" marL="0">
-              <a:buNone/>
-            </a:pPr>
-            <a:r>
-              <a:rPr lang="en-US" altLang="en-US" sz="1800" i="1" dirty="0">
-                <a:solidFill>
-                  <a:srgbClr val="555555"/>
-                </a:solidFill>
-                <a:latin typeface="Times New Roman" pitchFamily="34" charset="0"/>
-                <a:ea typeface="宋体" pitchFamily="2" charset="-122"/>
-                <a:cs typeface="Times New Roman" pitchFamily="34" charset="-120"/>
-              </a:rPr>
-              <a:t>ReFi-GAD · Relational Fingerprints (ICML 2026)</a:t>
-            </a:r>
-            <a:endParaRPr lang="en-US" sz="1800" dirty="0"/>
-          </a:p>
-        </p:txBody>
-      </p:sp>
-      <p:sp>
-        <p:nvSpPr>
-          <p:cNvPr id="13" name="Text 11"/>
-          <p:cNvSpPr/>
-          <p:nvPr/>
-        </p:nvSpPr>
-        <p:spPr>
-          <a:xfrm>
-            <a:off x="4572000" y="3781552"/>
-            <a:ext cx="7162495" cy="411480"/>
-          </a:xfrm>
-          <a:prstGeom prst="rect">
-            <a:avLst/>
-          </a:prstGeom>
-          <a:noFill/>
-          <a:ln/>
-        </p:spPr>
-        <p:txBody>
-          <a:bodyPr wrap="square" lIns="0" tIns="0" rIns="0" bIns="0" rtlCol="0" anchor="ctr"/>
-          <a:lstStyle/>
-          <a:p>
-            <a:pPr algn="l" indent="0" marL="0">
-              <a:buNone/>
-            </a:pPr>
-            <a:r>
-              <a:rPr lang="en-US" altLang="en-US" sz="1800" i="1" dirty="0">
-                <a:solidFill>
-                  <a:srgbClr val="555555"/>
-                </a:solidFill>
-                <a:latin typeface="Times New Roman" pitchFamily="34" charset="0"/>
-                <a:ea typeface="宋体" pitchFamily="2" charset="-122"/>
-                <a:cs typeface="Times New Roman" pitchFamily="34" charset="-120"/>
-              </a:rPr>
-              <a:t>AG-Forge + TS-GGAD · Synthetic Training (arXiv 2026)</a:t>
-            </a:r>
-            <a:endParaRPr lang="en-US" sz="1800" dirty="0"/>
-          </a:p>
-        </p:txBody>
-      </p:sp>
-      <p:sp>
-        <p:nvSpPr>
-          <p:cNvPr id="14" name="Shape 12"/>
-          <p:cNvSpPr/>
-          <p:nvPr/>
-        </p:nvSpPr>
-        <p:spPr>
-          <a:xfrm>
-            <a:off x="4572000" y="5303520"/>
-            <a:ext cx="6858000" cy="36576"/>
-          </a:xfrm>
-          <a:prstGeom prst="rect">
-            <a:avLst/>
-          </a:prstGeom>
-          <a:solidFill>
-            <a:srgbClr val="E8E2F5"/>
-          </a:solidFill>
-          <a:ln/>
-        </p:spPr>
-      </p:sp>
-      <p:sp>
-        <p:nvSpPr>
-          <p:cNvPr id="15" name="Text 13"/>
-          <p:cNvSpPr/>
-          <p:nvPr/>
-        </p:nvSpPr>
-        <p:spPr>
-          <a:xfrm>
-            <a:off x="4572000" y="5486400"/>
-            <a:ext cx="7162495" cy="365760"/>
-          </a:xfrm>
-          <a:prstGeom prst="rect">
-            <a:avLst/>
-          </a:prstGeom>
-          <a:noFill/>
-          <a:ln/>
-        </p:spPr>
-        <p:txBody>
-          <a:bodyPr wrap="square" lIns="0" tIns="0" rIns="0" bIns="0" rtlCol="0" anchor="ctr"/>
-          <a:lstStyle/>
-          <a:p>
-            <a:pPr algn="l" indent="0" marL="0">
-              <a:buNone/>
-            </a:pPr>
-            <a:r>
-              <a:rPr lang="zh-CN" altLang="en-US" sz="1500" dirty="0">
-                <a:solidFill>
-                  <a:srgbClr val="999999"/>
-                </a:solidFill>
-                <a:latin typeface="Times New Roman" pitchFamily="34" charset="0"/>
-                <a:ea typeface="宋体" pitchFamily="2" charset="-122"/>
-                <a:cs typeface="Times New Roman" pitchFamily="34" charset="-120"/>
-              </a:rPr>
-              <a:t>汇 报 人：</a:t>
-            </a:r>
-            <a:pPr algn="l" indent="0" marL="0">
-              <a:buNone/>
-            </a:pPr>
-            <a:r>
-              <a:rPr lang="zh-CN" altLang="en-US" sz="1700" dirty="0">
-                <a:solidFill>
-                  <a:srgbClr val="1A1A1A"/>
-                </a:solidFill>
-                <a:latin typeface="Times New Roman" pitchFamily="34" charset="0"/>
-                <a:ea typeface="宋体" pitchFamily="2" charset="-122"/>
-                <a:cs typeface="Times New Roman" pitchFamily="34" charset="-120"/>
-              </a:rPr>
-              <a:t>[ 汇报人姓名 ]</a:t>
-            </a:r>
-            <a:endParaRPr lang="en-US" sz="1500" dirty="0"/>
-          </a:p>
-        </p:txBody>
-      </p:sp>
-      <p:sp>
-        <p:nvSpPr>
-          <p:cNvPr id="16" name="Text 14"/>
-          <p:cNvSpPr/>
-          <p:nvPr/>
-        </p:nvSpPr>
-        <p:spPr>
-          <a:xfrm>
-            <a:off x="4572000" y="5897880"/>
-            <a:ext cx="7162495" cy="365760"/>
-          </a:xfrm>
-          <a:prstGeom prst="rect">
-            <a:avLst/>
-          </a:prstGeom>
-          <a:noFill/>
-          <a:ln/>
-        </p:spPr>
-        <p:txBody>
-          <a:bodyPr wrap="square" lIns="0" tIns="0" rIns="0" bIns="0" rtlCol="0" anchor="ctr"/>
-          <a:lstStyle/>
-          <a:p>
-            <a:pPr algn="l" indent="0" marL="0">
-              <a:buNone/>
-            </a:pPr>
-            <a:r>
-              <a:rPr lang="zh-CN" altLang="en-US" sz="1500" dirty="0">
-                <a:solidFill>
-                  <a:srgbClr val="999999"/>
-                </a:solidFill>
-                <a:latin typeface="Times New Roman" pitchFamily="34" charset="0"/>
-                <a:ea typeface="宋体" pitchFamily="2" charset="-122"/>
-                <a:cs typeface="Times New Roman" pitchFamily="34" charset="-120"/>
-              </a:rPr>
-              <a:t>论文作者：</a:t>
-            </a:r>
-            <a:pPr algn="l" indent="0" marL="0">
-              <a:buNone/>
-            </a:pPr>
-            <a:r>
-              <a:rPr lang="zh-CN" altLang="en-US" sz="1700" dirty="0">
-                <a:solidFill>
-                  <a:srgbClr val="1A1A1A"/>
-                </a:solidFill>
-                <a:latin typeface="Times New Roman" pitchFamily="34" charset="0"/>
-                <a:ea typeface="宋体" pitchFamily="2" charset="-122"/>
-                <a:cs typeface="Times New Roman" pitchFamily="34" charset="-120"/>
-              </a:rPr>
-              <a:t>Griffith University &amp; 同济大学</a:t>
-            </a:r>
-            <a:endParaRPr lang="en-US" sz="1500" dirty="0"/>
-          </a:p>
-        </p:txBody>
-      </p:sp>
-      <p:sp>
-        <p:nvSpPr>
-          <p:cNvPr id="17" name="Text 15"/>
+          <p:cNvPr id="27" name="Text 25"/>
           <p:cNvSpPr/>
           <p:nvPr/>
         </p:nvSpPr>
@@ -5557,7 +5889,7 @@
       </p:sp>
       <p:pic>
         <p:nvPicPr>
-          <p:cNvPr id="13" name="Image 0" descr="/tmp/claude-0/-home-claude/1c849058-b4f4-5336-952a-c7ce1c209b85/scratchpad/rr/build/figs/refi_framework.png">    </p:cNvPr>
+          <p:cNvPr id="13" name="Image 0" descr="/tmp/rr-demo/figs/refi_framework.png">    </p:cNvPr>
           <p:cNvPicPr>
             <a:picLocks noChangeAspect="1"/>
           </p:cNvPicPr>
@@ -17676,7 +18008,7 @@
       </p:sp>
       <p:pic>
         <p:nvPicPr>
-          <p:cNvPr id="13" name="Image 0" descr="/tmp/claude-0/-home-claude/1c849058-b4f4-5336-952a-c7ce1c209b85/scratchpad/rr/build/figs/forge_fig1.png">    </p:cNvPr>
+          <p:cNvPr id="13" name="Image 0" descr="/tmp/rr-demo/figs/forge_fig1.png">    </p:cNvPr>
           <p:cNvPicPr>
             <a:picLocks noChangeAspect="1"/>
           </p:cNvPicPr>
@@ -20469,7 +20801,7 @@
       </p:sp>
       <p:pic>
         <p:nvPicPr>
-          <p:cNvPr id="13" name="Image 0" descr="/tmp/claude-0/-home-claude/1c849058-b4f4-5336-952a-c7ce1c209b85/scratchpad/rr/build/figs/forge_framework.png">    </p:cNvPr>
+          <p:cNvPr id="13" name="Image 0" descr="/tmp/rr-demo/figs/forge_framework.png">    </p:cNvPr>
           <p:cNvPicPr>
             <a:picLocks noChangeAspect="1"/>
           </p:cNvPicPr>
@@ -31370,7 +31702,7 @@
                 <a:ea typeface="宋体" pitchFamily="2" charset="-122"/>
                 <a:cs typeface="Times New Roman" pitchFamily="34" charset="-120"/>
               </a:rPr>
-              <a:t>支撑集大小影响明显，横向比较前要先对齐设定</a:t>
+              <a:t>两篇设定不同（支撑集 50 vs 30），差异来源需要控制变量复现；横向比较前先对齐设定</a:t>
             </a:r>
             <a:endParaRPr lang="en-US" sz="1500" dirty="0"/>
           </a:p>
@@ -31431,7 +31763,7 @@
                 <a:ea typeface="宋体" pitchFamily="2" charset="-122"/>
                 <a:cs typeface="Times New Roman" pitchFamily="34" charset="-120"/>
               </a:rPr>
-              <a:t>正文数字与表格不一致</a:t>
+              <a:t>同一消融，统计范围不同</a:t>
             </a:r>
             <a:endParaRPr lang="en-US" sz="1800" dirty="0"/>
           </a:p>
@@ -31490,7 +31822,7 @@
                 <a:ea typeface="宋体" pitchFamily="2" charset="-122"/>
                 <a:cs typeface="Times New Roman" pitchFamily="34" charset="-120"/>
               </a:rPr>
-              <a:t>论文一称 w/o R、w/o D 的差距为 20.39%、0.70%；按表 2 计算为 24.10、0.88</a:t>
+              <a:t>正文 20.39 / 0.70 按全部 14 个数据集计（附录 Table 8）；正文表 2 只列 Group 2，算出来是 24.10 / 0.88</a:t>
             </a:r>
             <a:endParaRPr lang="en-US" sz="1500" dirty="0"/>
           </a:p>
@@ -38712,7 +39044,7 @@
       </p:sp>
       <p:pic>
         <p:nvPicPr>
-          <p:cNvPr id="13" name="Image 0" descr="/tmp/claude-0/-home-claude/1c849058-b4f4-5336-952a-c7ce1c209b85/scratchpad/rr/build/figs/refi_fig1.png">    </p:cNvPr>
+          <p:cNvPr id="13" name="Image 0" descr="/tmp/rr-demo/figs/refi_fig1.png">    </p:cNvPr>
           <p:cNvPicPr>
             <a:picLocks noChangeAspect="1"/>
           </p:cNvPicPr>
@@ -39749,7 +40081,7 @@
       </p:sp>
       <p:pic>
         <p:nvPicPr>
-          <p:cNvPr id="13" name="Image 0" descr="/tmp/claude-0/-home-claude/1c849058-b4f4-5336-952a-c7ce1c209b85/scratchpad/rr/build/figs/refi_fig2.png">    </p:cNvPr>
+          <p:cNvPr id="13" name="Image 0" descr="/tmp/rr-demo/figs/refi_fig2.png">    </p:cNvPr>
           <p:cNvPicPr>
             <a:picLocks noChangeAspect="1"/>
           </p:cNvPicPr>
@@ -39763,8 +40095,8 @@
         </p:blipFill>
         <p:spPr>
           <a:xfrm>
-            <a:off x="502920" y="2865943"/>
-            <a:ext cx="6035040" cy="2902062"/>
+            <a:off x="502920" y="2865468"/>
+            <a:ext cx="6035040" cy="2903012"/>
           </a:xfrm>
           <a:prstGeom prst="rect">
             <a:avLst/>
@@ -39779,8 +40111,8 @@
         </p:nvSpPr>
         <p:spPr>
           <a:xfrm>
-            <a:off x="502920" y="2865943"/>
-            <a:ext cx="6035040" cy="2902062"/>
+            <a:off x="502920" y="2865468"/>
+            <a:ext cx="6035040" cy="2903012"/>
           </a:xfrm>
           <a:prstGeom prst="rect">
             <a:avLst/>
@@ -39801,7 +40133,7 @@
         </p:nvSpPr>
         <p:spPr>
           <a:xfrm>
-            <a:off x="365760" y="5813725"/>
+            <a:off x="365760" y="5814200"/>
             <a:ext cx="6400800" cy="256032"/>
           </a:xfrm>
           <a:prstGeom prst="rect">

</xml_diff>